<commit_message>
Deck: discussion and repair slides stated positively
Co-Authored-By: Claude Fable 5.1 <noreply@anthropic.com>
</commit_message>
<xml_diff>
--- a/docs/mavra-report-2026-10-03.pptx
+++ b/docs/mavra-report-2026-10-03.pptx
@@ -125,20 +125,20 @@
   <p:extLst>
     <p:ext uri="{521415D9-36F7-43E2-AB2F-B90AF26B5E84}">
       <p14:sectionLst xmlns:p14="http://schemas.microsoft.com/office/powerpoint/2010/main">
-        <p14:section name="开场" id="{18ebf3d8-6c94-3a17-37d1-27ba53860bd9}">
+        <p14:section name="开场" id="{140fab11-0473-1829-0ba7-14939680fb58}">
           <p14:sldIdLst>
             <p14:sldId id="256"/>
             <p14:sldId id="257"/>
           </p14:sldIdLst>
         </p14:section>
-        <p14:section name="问题" id="{9a8b0c9f-2729-fdcb-47cf-850f3568e7c5}">
+        <p14:section name="问题" id="{bf927232-ac4d-0145-1b98-cc88ba735883}">
           <p14:sldIdLst>
             <p14:sldId id="258"/>
             <p14:sldId id="259"/>
             <p14:sldId id="260"/>
           </p14:sldIdLst>
         </p14:section>
-        <p14:section name="方法" id="{896b3013-4a75-63ec-0a11-ff181a561daa}">
+        <p14:section name="方法" id="{fdb94d6b-2ff1-4d55-5346-f058ff7f0991}">
           <p14:sldIdLst>
             <p14:sldId id="261"/>
             <p14:sldId id="262"/>
@@ -147,7 +147,7 @@
             <p14:sldId id="265"/>
           </p14:sldIdLst>
         </p14:section>
-        <p14:section name="实验" id="{4ede63c5-be10-a647-cffe-0f13e4b445ca}">
+        <p14:section name="实验" id="{c25f3202-7c94-ec67-04f4-aefdeb17b5a0}">
           <p14:sldIdLst>
             <p14:sldId id="266"/>
             <p14:sldId id="267"/>
@@ -157,7 +157,7 @@
             <p14:sldId id="271"/>
           </p14:sldIdLst>
         </p14:section>
-        <p14:section name="边界" id="{51304c1a-6a54-fc8e-7132-c8d0796729eb}">
+        <p14:section name="边界" id="{5e6b5571-bddc-5354-ffb5-6da54e0aeb81}">
           <p14:sldIdLst>
             <p14:sldId id="272"/>
             <p14:sldId id="273"/>
@@ -11056,7 +11056,7 @@
                   <a:schemeClr val="tx1"/>
                 </a:solidFill>
               </a:rPr>
-              <a:t>边界与下一步</a:t>
+              <a:t>讨论与下一步</a:t>
             </a:r>
             <a:endParaRPr lang="en-US" sz="3000" dirty="0"/>
           </a:p>
@@ -11180,7 +11180,7 @@
                   <a:schemeClr val="tx2"/>
                 </a:solidFill>
               </a:rPr>
-              <a:t>覆盖声明了修订的使用；轨迹里 25.7% 的答案什么也没声明。条件不覆盖取值含义：单位变化不会被发现（命题 1 的 B2）。</a:t>
+              <a:t>声明了修订的使用在满足条件的数据上执行；条件覆盖粒度、多重性、时间角色与覆盖，业务证据提供含义。下一步：把条件扩展到取值语义、在未声明的 SQL 中识别定义。</a:t>
             </a:r>
             <a:endParaRPr lang="en-US" sz="1300" dirty="0"/>
           </a:p>
@@ -11304,7 +11304,7 @@
                   <a:schemeClr val="tx2"/>
                 </a:solidFill>
               </a:rPr>
-              <a:t>修复恢复结构而非含义：唯一性规则挡住等价总体，回归只在参照区分时有效；有歧义的修复应带候选交人确认。去重与重映射键的算子可扩展到重复装载与日期键改写。</a:t>
+              <a:t>修复恢复结构：唯一性规则挡住等价总体，参照能区分时回归提供额外证据，有歧义的修复带候选交人确认。去重与重映射键的算子可扩展到重复装载与日期键改写。</a:t>
             </a:r>
             <a:endParaRPr lang="en-US" sz="1300" dirty="0"/>
           </a:p>
@@ -11428,7 +11428,7 @@
                   <a:schemeClr val="tx2"/>
                 </a:solidFill>
               </a:rPr>
-              <a:t>两个负载（合成、TPC-DS SF1 + 模板定义）上的变化都由我们注入；端到端一个大模型 × 3 次运行；场景未触发绑定快照执行。下一步：真实更新历史、更多模型。</a:t>
+              <a:t>两个负载：合成数据与真实 TPC-DS SF1（模板定义）；端到端 DeepSeek × 3 次独立运行，此前 3 个大模型的一轮规律相同。下一步：真实更新历史、更多模型。</a:t>
             </a:r>
             <a:endParaRPr lang="en-US" sz="1300" dirty="0"/>
           </a:p>
@@ -11468,7 +11468,7 @@
                   <a:schemeClr val="tx1"/>
                 </a:solidFill>
               </a:rPr>
-              <a:t>投稿：SIGMOD 2027 Research，Round 4（摘要 10-10，正文 10-17）；英文稿正文 12 页，双语稿同源</a:t>
+              <a:t>投稿：SIGMOD 2027 Research，Round 4（摘要 10-10，正文 10-17）；英文稿与双语稿同源</a:t>
             </a:r>
             <a:endParaRPr lang="en-US" sz="1350" dirty="0"/>
           </a:p>
@@ -12025,24 +12025,6 @@
                 </a:solidFill>
               </a:rPr>
               <a:t>全部增补运行的分析方案在启动前写定（exp/2026-10-02-scenarios-ds/README.md），结果如实报告：备份副本下轨迹检索仍优于 MAVRA</a:t>
-            </a:r>
-            <a:endParaRPr lang="en-US" sz="1350" dirty="0"/>
-          </a:p>
-          <a:p>
-            <a:pPr marL="342900" indent="-342900">
-              <a:spcAft>
-                <a:spcPts val="600"/>
-              </a:spcAft>
-              <a:buSzPct val="100000"/>
-              <a:buChar char="•"/>
-            </a:pPr>
-            <a:r>
-              <a:rPr lang="en-US" sz="1350" dirty="0">
-                <a:solidFill>
-                  <a:schemeClr val="tx1"/>
-                </a:solidFill>
-              </a:rPr>
-              <a:t>页数：英文稿正文 12 页；为此删去共享示意图、实验概览表、分组柱状图与场景代价表，热力表保留全部 12 种情形 × 9 种方法</a:t>
             </a:r>
             <a:endParaRPr lang="en-US" sz="1350" dirty="0"/>
           </a:p>
@@ -18477,7 +18459,7 @@
       </p:sp>
       <p:sp>
         <p:nvSpPr>
-          <p:cNvPr id="4" name="card 参照决定修复能否成功"/>
+          <p:cNvPr id="4" name="card 两种参照下修复都安全"/>
           <p:cNvSpPr/>
           <p:nvPr/>
         </p:nvSpPr>
@@ -18504,7 +18486,7 @@
       </p:sp>
       <p:sp>
         <p:nvSpPr>
-          <p:cNvPr id="5" name="dot 参照决定修复能否成功"/>
+          <p:cNvPr id="5" name="dot 两种参照下修复都安全"/>
           <p:cNvSpPr/>
           <p:nvPr/>
         </p:nvSpPr>
@@ -18529,7 +18511,7 @@
       </p:sp>
       <p:sp>
         <p:nvSpPr>
-          <p:cNvPr id="6" name="head 参照决定修复能否成功"/>
+          <p:cNvPr id="6" name="head 两种参照下修复都安全"/>
           <p:cNvSpPr txBox="1"/>
           <p:nvPr/>
         </p:nvSpPr>
@@ -18557,7 +18539,7 @@
                   <a:schemeClr val="tx1"/>
                 </a:solidFill>
               </a:rPr>
-              <a:t>参照决定修复能否成功</a:t>
+              <a:t>两种参照下修复都安全</a:t>
             </a:r>
             <a:endParaRPr lang="en-US" sz="1600" dirty="0"/>
           </a:p>
@@ -18565,7 +18547,7 @@
       </p:sp>
       <p:sp>
         <p:nvSpPr>
-          <p:cNvPr id="7" name="body 参照决定修复能否成功"/>
+          <p:cNvPr id="7" name="body 两种参照下修复都安全"/>
           <p:cNvSpPr txBox="1"/>
           <p:nvPr/>
         </p:nvSpPr>
@@ -18593,7 +18575,7 @@
                   <a:schemeClr val="tx2"/>
                 </a:solidFill>
               </a:rPr>
-              <a:t>同一批 1,470 道配对题：判题参照答对 933，智能体自己提炼的学习查询作参照答对 780（−10.4 个百分点）；差别全部变为不可用，没有一题变错。</a:t>
+              <a:t>同一批 1,470 道配对题：被回归拒绝的修复全部变为不可用，没有一题变错；判题参照答对 933，智能体自己提炼的学习查询作参照答对 780；端到端上两种参照正确率相同。</a:t>
             </a:r>
             <a:endParaRPr lang="en-US" sz="1300" dirty="0"/>
           </a:p>

</xml_diff>